<commit_message>
Catalogo EPC: valida deck v2 com conteudo oficial (APIs sem preco/atributo, DataPacks/IDX, Agentforce consome catalogo)
Co-Authored-By: Claude Fable 5.1 <noreply@anthropic.com>
Claude-Session: https://claude.ai/code/session_01FufmY5Q9iS5xTS4p1D8GUr
</commit_message>
<xml_diff>
--- a/docs/deck-catalogo/Catalogo_Carga_e_Manutencao_v2_Rota_Padrao.pptx
+++ b/docs/deck-catalogo/Catalogo_Carga_e_Manutencao_v2_Rota_Padrao.pptx
@@ -7777,7 +7777,7 @@
                 <a:latin typeface="Calibri"/>
                 <a:cs typeface="Calibri"/>
               </a:rPr>
-              <a:t>Salesforce Help, Trailhead e Developer Docs (EPC, CPQ e Agentforce), consultados em 16/09</a:t>
+              <a:t>Salesforce Help, Developer Docs e anúncio oficial, conferidos em 16/09</a:t>
             </a:r>
           </a:p>
         </p:txBody>
@@ -7930,7 +7930,7 @@
                 <a:latin typeface="Calibri"/>
                 <a:cs typeface="Calibri"/>
               </a:rPr>
-              <a:t>Forma oficial de mover o catálogo entre orgs; o DataPack de Product2 já carrega as entradas de preço.</a:t>
+              <a:t>Help do EPC: para mover de desenvolvimento para produção, usa-se Vlocity DataPacks; o EPC usa o IDX Workbench como ferramenta de build.</a:t>
             </a:r>
           </a:p>
           <a:p>
@@ -7949,7 +7949,7 @@
                 <a:latin typeface="Calibri"/>
                 <a:cs typeface="Calibri"/>
               </a:rPr>
-              <a:t>Chaves globais geradas por job do EPC; a doc é explícita: produtos não migram entre orgs por CSV.</a:t>
+              <a:t>O DataPack de Product2 já carrega as entradas de preço; produtos não migram entre orgs por CSV.</a:t>
             </a:r>
           </a:p>
         </p:txBody>
@@ -8016,7 +8016,7 @@
                 <a:latin typeface="Calibri"/>
                 <a:cs typeface="Calibri"/>
               </a:rPr>
-              <a:t>APIs oficiais (Admin Configure: Product, Picklist e Promotion v2) para criar produtos, filhos, versões e promoções.</a:t>
+              <a:t>CRUD oficial só de Product2, versão, filho, picklist e promoção. Não cobrem preço nem atributo: um carregador teria de gravar isso por fora, sem validação.</a:t>
             </a:r>
           </a:p>
           <a:p>
@@ -8121,7 +8121,7 @@
                 <a:latin typeface="Calibri"/>
                 <a:cs typeface="Calibri"/>
               </a:rPr>
-              <a:t>Agentforce for Communications (GA 2026) traz 5 agentes: faturamento, SLO, cotação, agrupamento de sites e venda guiada. Nenhum cria catálogo.</a:t>
+              <a:t>Agentforce for Communications (26/02/2026): 5 agentes, faturamento, SLO, cotação, agrupamento de sites e venda guiada. Todos consomem o catálogo; nenhum o cria.</a:t>
             </a:r>
           </a:p>
         </p:txBody>
@@ -8545,7 +8545,7 @@
                 <a:latin typeface="Calibri"/>
                 <a:cs typeface="Calibri"/>
               </a:rPr>
-              <a:t>Reimplementa validações que o Product Designer já faz: cada regra esquecida vira erro no carrinho.</a:t>
+              <a:t>Reimplementa validações que o Product Designer já faz; as APIs oficiais nem cobrem preço e atributo, então o wizard gravaria isso direto na base.</a:t>
             </a:r>
           </a:p>
           <a:p>
@@ -9374,7 +9374,7 @@
                 <a:latin typeface="Calibri"/>
                 <a:cs typeface="Calibri"/>
               </a:rPr>
-              <a:t>Agentforce for Communications: agentes de faturamento, SLO, cotação, sites e venda guiada. Nenhum tópico ou ação pré-construída cria ou mantém catálogo.</a:t>
+              <a:t>Agentforce for Communications: faturamento, SLO, cotação, sites e venda guiada. Nenhum cria ou mantém catálogo; o de cotação depende de um catálogo bem cadastrado.</a:t>
             </a:r>
           </a:p>
         </p:txBody>
@@ -9440,7 +9440,7 @@
                 <a:latin typeface="Calibri"/>
                 <a:cs typeface="Calibri"/>
               </a:rPr>
-              <a:t>Ações em Flow ou Apex sobre as EPC REST APIs, prompt templates, testes e guardrails. Volta a ser código custom, com a mesma manutenção do wizard.</a:t>
+              <a:t>Ações em Flow ou Apex sobre as EPC REST APIs (que não cobrem preço nem atributo), prompt templates, testes e guardrails. Volta a ser código custom.</a:t>
             </a:r>
           </a:p>
         </p:txBody>

</xml_diff>

<commit_message>
Catalogo EPC: jobs pos-carga em janela (Help: nao rodar em producao ao vivo); Agentforce no pacote CME e escopo carrinho
Co-Authored-By: Claude Fable 5.1 <noreply@anthropic.com>
Claude-Session: https://claude.ai/code/session_01FufmY5Q9iS5xTS4p1D8GUr
</commit_message>
<xml_diff>
--- a/docs/deck-catalogo/Catalogo_Carga_e_Manutencao_v2_Rota_Padrao.pptx
+++ b/docs/deck-catalogo/Catalogo_Carga_e_Manutencao_v2_Rota_Padrao.pptx
@@ -4083,7 +4083,7 @@
                 <a:latin typeface="Calibri"/>
                 <a:cs typeface="Calibri"/>
               </a:rPr>
-              <a:t>Pós-carga controlado</a:t>
+              <a:t>Pós-carga em janela</a:t>
             </a:r>
           </a:p>
           <a:p>
@@ -4101,7 +4101,7 @@
                 <a:latin typeface="Calibri"/>
                 <a:cs typeface="Calibri"/>
               </a:rPr>
-              <a:t>Jobs de hierarquia e cache na ordem documentada, em checklist ou disparados por API.</a:t>
+              <a:t>Jobs de hierarquia e cache na ordem documentada, em janela fora do horário de venda: a Help manda não rodar jobs de administração em produção ao vivo.</a:t>
             </a:r>
           </a:p>
         </p:txBody>
@@ -4913,7 +4913,7 @@
                 <a:latin typeface="Calibri"/>
                 <a:cs typeface="Calibri"/>
               </a:rPr>
-              <a:t>jobs de hierarquia e cache na ordem; roteiro de teste no carrinho.</a:t>
+              <a:t>jobs de hierarquia e cache na ordem, em janela de manutenção; roteiro de teste no carrinho.</a:t>
             </a:r>
           </a:p>
           <a:p>
@@ -8102,7 +8102,7 @@
                 <a:latin typeface="Calibri"/>
                 <a:cs typeface="Calibri"/>
               </a:rPr>
-              <a:t>Após mudar estrutura: Product Hierarchy Maintenance, Clear Managed Platform Cache e Refresh Platform Cache, nesta ordem; executáveis por API.</a:t>
+              <a:t>Após mudar estrutura: Product Hierarchy Maintenance, Clear Managed Platform Cache e Refresh Platform Cache, nesta ordem, por API ou pela aba Vlocity CMT Administration, nunca em produção ao vivo.</a:t>
             </a:r>
           </a:p>
           <a:p>
@@ -8121,7 +8121,7 @@
                 <a:latin typeface="Calibri"/>
                 <a:cs typeface="Calibri"/>
               </a:rPr>
-              <a:t>Agentforce for Communications (26/02/2026): 5 agentes, faturamento, SLO, cotação, agrupamento de sites e venda guiada. Todos consomem o catálogo; nenhum o cria.</a:t>
+              <a:t>Agentforce for Communications (26/02/2026): 5 agentes, faturamento, SLO, cotação, sites e venda guiada. No pacote CME, as ações padrão de Agentforce são para o carrinho. Nenhuma cria catálogo.</a:t>
             </a:r>
           </a:p>
         </p:txBody>

</xml_diff>

<commit_message>
Catalogo EPC: sequencia oficial do Product Designer, projetos do EPC e ciclo de vida no deck v2
Co-Authored-By: Claude Fable 5.1 <noreply@anthropic.com>
Claude-Session: https://claude.ai/code/session_01FufmY5Q9iS5xTS4p1D8GUr
</commit_message>
<xml_diff>
--- a/docs/deck-catalogo/Catalogo_Carga_e_Manutencao_v2_Rota_Padrao.pptx
+++ b/docs/deck-catalogo/Catalogo_Carga_e_Manutencao_v2_Rota_Padrao.pptx
@@ -3960,7 +3960,7 @@
                 <a:latin typeface="Calibri"/>
                 <a:cs typeface="Calibri"/>
               </a:rPr>
-              <a:t>O DataPack de cada onda fica guardado; o histórico do Salesforce registra quem alterou o quê.</a:t>
+              <a:t>Projetos do EPC registram toda mudança do catálogo; o DataPack de cada onda fica guardado; versionamento de produto é nativo.</a:t>
             </a:r>
           </a:p>
         </p:txBody>
@@ -4242,7 +4242,7 @@
                 <a:latin typeface="Calibri"/>
                 <a:cs typeface="Calibri"/>
               </a:rPr>
-              <a:t>Oferta errada é inativada, não excluída; cada etapa tem dono e substituto nomeados.</a:t>
+              <a:t>Oferta errada é aposentada pelo ciclo de vida, não excluída; cada etapa tem dono e substituto nomeados.</a:t>
             </a:r>
           </a:p>
         </p:txBody>
@@ -4493,7 +4493,7 @@
                 <a:latin typeface="Calibri"/>
                 <a:cs typeface="Calibri"/>
               </a:rPr>
-              <a:t>Product Designer</a:t>
+              <a:t>tipo de objeto + oferta</a:t>
             </a:r>
           </a:p>
         </p:txBody>
@@ -4557,7 +4557,7 @@
                 <a:latin typeface="Calibri"/>
                 <a:cs typeface="Calibri"/>
               </a:rPr>
-              <a:t>aba Estrutura</a:t>
+              <a:t>estrutura e cardinalidade</a:t>
             </a:r>
           </a:p>
         </p:txBody>
@@ -4621,7 +4621,7 @@
                 <a:latin typeface="Calibri"/>
                 <a:cs typeface="Calibri"/>
               </a:rPr>
-              <a:t>aba Preços + regra</a:t>
+              <a:t>promoção no pacote</a:t>
             </a:r>
           </a:p>
         </p:txBody>
@@ -4685,7 +4685,7 @@
                 <a:latin typeface="Calibri"/>
                 <a:cs typeface="Calibri"/>
               </a:rPr>
-              <a:t>lista de preço</a:t>
+              <a:t>Pricing Designer</a:t>
             </a:r>
           </a:p>
         </p:txBody>
@@ -4749,7 +4749,7 @@
                 <a:latin typeface="Calibri"/>
                 <a:cs typeface="Calibri"/>
               </a:rPr>
-              <a:t>inativar + jobs</a:t>
+              <a:t>ciclo de vida: aposentar</a:t>
             </a:r>
           </a:p>
         </p:txBody>
@@ -4942,7 +4942,7 @@
                 <a:latin typeface="Calibri"/>
                 <a:cs typeface="Calibri"/>
               </a:rPr>
-              <a:t>DataPack exportado, resultado do teste e registro no diário.</a:t>
+              <a:t>projeto do EPC aberto para o evento, DataPack exportado, resultado do teste e registro no diário.</a:t>
             </a:r>
           </a:p>
         </p:txBody>
@@ -5066,7 +5066,7 @@
                 <a:latin typeface="Calibri"/>
                 <a:cs typeface="Calibri"/>
               </a:rPr>
-              <a:t>Erros comuns e como corrigir (oferta não aparece no carrinho, job não executado, preço errado).</a:t>
+              <a:t>Erros comuns e como corrigir (oferta não aparece no carrinho, job não executado, preço errado, vírgula em valor de picklist).</a:t>
             </a:r>
           </a:p>
           <a:p>
@@ -7844,7 +7844,7 @@
                 <a:latin typeface="Calibri"/>
                 <a:cs typeface="Calibri"/>
               </a:rPr>
-              <a:t>App Lightning oficial, foco das novas funcionalidades; substitui o Product Console.</a:t>
+              <a:t>Help: é a aplicação de administração do catálogo, para usuários de negócio e de TI. Sequência oficial: tipos de objeto e atributos, especificação, oferta, pacote com cardinalidade, preço e promoção.</a:t>
             </a:r>
           </a:p>
           <a:p>
@@ -7863,7 +7863,7 @@
                 <a:latin typeface="Calibri"/>
                 <a:cs typeface="Calibri"/>
               </a:rPr>
-              <a:t>Cria a oferta em sequência: produto, aba Estrutura (filhos e cardinalidade), atributos, aba Preços (lista de preço e promoção) e regras de contexto.</a:t>
+              <a:t>Projetos do EPC registram toda mudança no catálogo; versionamento de produto e ciclo de vida (atual, futuro, passado, aposentado) são nativos.</a:t>
             </a:r>
           </a:p>
         </p:txBody>

</xml_diff>

<commit_message>
Catalogo EPC: jobs de manutencao confirmados, Agentforce carrinho no pacote, projetos do EPC migrados pelo IDX; deck v2 final
Co-Authored-By: Claude Fable 5.1 <noreply@anthropic.com>
Claude-Session: https://claude.ai/code/session_01FufmY5Q9iS5xTS4p1D8GUr
</commit_message>
<xml_diff>
--- a/docs/deck-catalogo/Catalogo_Carga_e_Manutencao_v2_Rota_Padrao.pptx
+++ b/docs/deck-catalogo/Catalogo_Carga_e_Manutencao_v2_Rota_Padrao.pptx
@@ -3819,7 +3819,7 @@
                 <a:latin typeface="Calibri"/>
                 <a:cs typeface="Calibri"/>
               </a:rPr>
-              <a:t>Toda oferta nasce em sandbox, é testada no carrinho e só então migra, por DataPack.</a:t>
+              <a:t>Toda oferta nasce em sandbox, é testada no carrinho e só então migra, pelo IDX Workbench, a partir do projeto Released.</a:t>
             </a:r>
           </a:p>
         </p:txBody>
@@ -3960,7 +3960,7 @@
                 <a:latin typeface="Calibri"/>
                 <a:cs typeface="Calibri"/>
               </a:rPr>
-              <a:t>Projetos do EPC registram toda mudança do catálogo; o DataPack de cada onda fica guardado; versionamento de produto é nativo.</a:t>
+              <a:t>O projeto do EPC lista cada item alterado (Add, Change, Delete); o DataPack de cada onda fica guardado; versionamento é nativo.</a:t>
             </a:r>
           </a:p>
         </p:txBody>
@@ -4101,7 +4101,7 @@
                 <a:latin typeface="Calibri"/>
                 <a:cs typeface="Calibri"/>
               </a:rPr>
-              <a:t>Jobs de hierarquia e cache na ordem documentada, em janela fora do horário de venda: a Help manda não rodar jobs de administração em produção ao vivo.</a:t>
+              <a:t>Product Hierarchy Maintenance e Refresh Platform Cache na ordem documentada, em janela fora do horário de venda: a Help manda não rodar jobs em produção ao vivo.</a:t>
             </a:r>
           </a:p>
         </p:txBody>
@@ -4826,7 +4826,7 @@
                 <a:latin typeface="Calibri"/>
                 <a:cs typeface="Calibri"/>
               </a:rPr>
-              <a:t>oferta aprovada pelo comercial, códigos e preços definidos na planilha de levantamento.</a:t>
+              <a:t>oferta aprovada pelo comercial, códigos e preços na planilha de levantamento; projeto do EPC do evento aberto e definido como padrão.</a:t>
             </a:r>
           </a:p>
           <a:p>
@@ -4913,7 +4913,7 @@
                 <a:latin typeface="Calibri"/>
                 <a:cs typeface="Calibri"/>
               </a:rPr>
-              <a:t>jobs de hierarquia e cache na ordem, em janela de manutenção; roteiro de teste no carrinho.</a:t>
+              <a:t>Product Hierarchy Maintenance e Refresh Platform Cache (Incremental) em janela; roteiro de teste no carrinho.</a:t>
             </a:r>
           </a:p>
           <a:p>
@@ -4942,7 +4942,7 @@
                 <a:latin typeface="Calibri"/>
                 <a:cs typeface="Calibri"/>
               </a:rPr>
-              <a:t>projeto do EPC aberto para o evento, DataPack exportado, resultado do teste e registro no diário.</a:t>
+              <a:t>projeto do EPC Released e migrado pelo IDX, resultado do teste e registro no diário.</a:t>
             </a:r>
           </a:p>
         </p:txBody>
@@ -5694,7 +5694,7 @@
                 <a:latin typeface="Calibri"/>
                 <a:cs typeface="Calibri"/>
               </a:rPr>
-              <a:t>Agentforce (fase 2, assistente)</a:t>
+              <a:t>Agentforce (fase 2)</a:t>
             </a:r>
           </a:p>
         </p:txBody>
@@ -5742,7 +5742,7 @@
                 <a:latin typeface="Calibri"/>
                 <a:cs typeface="Calibri"/>
               </a:rPr>
-              <a:t>Explica o manual, monta o checklist, confere levantamento e pós-carga. Nunca publica sem aprovação humana.</a:t>
+              <a:t>Vendedor: cotação e pedido pelo carrinho, pronto no pacote. Catálogo: explica o manual, monta checklist, confere pós-carga. Nunca publica.</a:t>
             </a:r>
           </a:p>
         </p:txBody>
@@ -7844,7 +7844,7 @@
                 <a:latin typeface="Calibri"/>
                 <a:cs typeface="Calibri"/>
               </a:rPr>
-              <a:t>Help: é a aplicação de administração do catálogo, para usuários de negócio e de TI. Sequência oficial: tipos de objeto e atributos, especificação, oferta, pacote com cardinalidade, preço e promoção.</a:t>
+              <a:t>Help: aplicação de administração do catálogo, para negócio e TI. Sequência oficial: tipos de objeto e atributos, especificação, oferta, pacote com cardinalidade, preço e promoção.</a:t>
             </a:r>
           </a:p>
           <a:p>
@@ -7863,7 +7863,7 @@
                 <a:latin typeface="Calibri"/>
                 <a:cs typeface="Calibri"/>
               </a:rPr>
-              <a:t>Projetos do EPC registram toda mudança no catálogo; versionamento de produto e ciclo de vida (atual, futuro, passado, aposentado) são nativos.</a:t>
+              <a:t>Projetos do EPC registram toda mudança (Add, Change, Delete) no projeto padrão; versionamento e ciclo de vida (atual, futuro, passado, aposentado) são nativos.</a:t>
             </a:r>
           </a:p>
         </p:txBody>
@@ -7930,7 +7930,7 @@
                 <a:latin typeface="Calibri"/>
                 <a:cs typeface="Calibri"/>
               </a:rPr>
-              <a:t>Help do EPC: para mover de desenvolvimento para produção, usa-se Vlocity DataPacks; o EPC usa o IDX Workbench como ferramenta de build.</a:t>
+              <a:t>Help do EPC: para mover de desenvolvimento para produção, usa-se Vlocity DataPacks e o IDX Workbench.</a:t>
             </a:r>
           </a:p>
           <a:p>
@@ -7949,7 +7949,7 @@
                 <a:latin typeface="Calibri"/>
                 <a:cs typeface="Calibri"/>
               </a:rPr>
-              <a:t>O DataPack de Product2 já carrega as entradas de preço; produtos não migram entre orgs por CSV.</a:t>
+              <a:t>O IDX Workbench migra exatamente as mudanças de um Projeto do EPC em status Released; produtos não migram entre orgs por CSV.</a:t>
             </a:r>
           </a:p>
         </p:txBody>
@@ -8102,7 +8102,7 @@
                 <a:latin typeface="Calibri"/>
                 <a:cs typeface="Calibri"/>
               </a:rPr>
-              <a:t>Após mudar estrutura: Product Hierarchy Maintenance, Clear Managed Platform Cache e Refresh Platform Cache, nesta ordem, por API ou pela aba Vlocity CMT Administration, nunca em produção ao vivo.</a:t>
+              <a:t>Jobs de manutenção (Help): Product Hierarchy Maintenance antes do Refresh Platform Cache; Full na carga, Incremental na manutenção; Clear Managed Platform Cache limpa a partição do CPQ. Nunca em produção ao vivo.</a:t>
             </a:r>
           </a:p>
           <a:p>
@@ -8121,7 +8121,7 @@
                 <a:latin typeface="Calibri"/>
                 <a:cs typeface="Calibri"/>
               </a:rPr>
-              <a:t>Agentforce for Communications (26/02/2026): 5 agentes, faturamento, SLO, cotação, sites e venda guiada. No pacote CME, as ações padrão de Agentforce são para o carrinho. Nenhuma cria catálogo.</a:t>
+              <a:t>Agentforce pronto no pacote CME: ações e flows para o carrinho (cotação, pedido, navegar produtos, atributos, promoções). Agentforce for Communications: 5 agentes de venda e serviço. Nenhum cria catálogo.</a:t>
             </a:r>
           </a:p>
         </p:txBody>
@@ -9374,7 +9374,7 @@
                 <a:latin typeface="Calibri"/>
                 <a:cs typeface="Calibri"/>
               </a:rPr>
-              <a:t>Agentforce for Communications: faturamento, SLO, cotação, sites e venda guiada. Nenhum cria ou mantém catálogo; o de cotação depende de um catálogo bem cadastrado.</a:t>
+              <a:t>Ações e flows prontos no pacote CME para operações de carrinho: criar cotação e pedido, navegar produtos, configurar atributos, aplicar promoções, sem Apex custom. Tudo consome o catálogo; nada o cria.</a:t>
             </a:r>
           </a:p>
         </p:txBody>
@@ -9573,7 +9573,7 @@
                 <a:latin typeface="Calibri"/>
                 <a:cs typeface="Calibri"/>
               </a:rPr>
-              <a:t>Reduz a dependência de especialista na rotina e nas dúvidas do dia a dia.</a:t>
+              <a:t>O ganho real e pronto é na venda: vendedor monta cotação e pedido pelo agente, sem Apex custom.</a:t>
             </a:r>
           </a:p>
           <a:p>
@@ -9592,7 +9592,7 @@
                 <a:latin typeface="Calibri"/>
                 <a:cs typeface="Calibri"/>
               </a:rPr>
-              <a:t>Padroniza o cadastro ao seguir o manual, sempre.</a:t>
+              <a:t>Como assistente da manutenção, padroniza o cadastro ao seguir o manual.</a:t>
             </a:r>
           </a:p>
           <a:p>
@@ -9762,7 +9762,7 @@
                 <a:latin typeface="Calibri"/>
                 <a:cs typeface="Calibri"/>
               </a:rPr>
-              <a:t>Sequência: carga pela rota padrão e manual primeiro; agente como piloto de apoio à manutenção, fase 2, se a licença compensar.</a:t>
+              <a:t>Sequência: carga pela rota padrão e manual primeiro; fase 2 com Agentforce onde está pronto (carrinho) e como assistente do manual, se a licença compensar.</a:t>
             </a:r>
           </a:p>
         </p:txBody>
@@ -13341,7 +13341,7 @@
                 <a:latin typeface="Calibri"/>
                 <a:cs typeface="Calibri"/>
               </a:rPr>
-              <a:t>11 ofertas de conectividade cadastradas em sandbox pelo Product Designer.</a:t>
+              <a:t>Projeto do EPC da onda aberto como padrão; 11 ofertas de conectividade cadastradas em sandbox.</a:t>
             </a:r>
           </a:p>
           <a:p>
@@ -13360,7 +13360,7 @@
                 <a:latin typeface="Calibri"/>
                 <a:cs typeface="Calibri"/>
               </a:rPr>
-              <a:t>Teste no carrinho por família; DataPack exportado e guardado.</a:t>
+              <a:t>Teste no carrinho por família; projeto Released e exportado.</a:t>
             </a:r>
           </a:p>
           <a:p>
@@ -13643,7 +13643,7 @@
                 <a:latin typeface="Calibri"/>
                 <a:cs typeface="Calibri"/>
               </a:rPr>
-              <a:t>Publicação em preprod e produção por DataPack, com os jobs na ordem.</a:t>
+              <a:t>Publicação em preprod e produção pelo IDX Workbench a partir dos projetos Released, jobs na ordem, em janela.</a:t>
             </a:r>
           </a:p>
           <a:p>
@@ -13681,7 +13681,7 @@
                 <a:latin typeface="Calibri"/>
                 <a:cs typeface="Calibri"/>
               </a:rPr>
-              <a:t>Decisão sobre o piloto do Agentforce.</a:t>
+              <a:t>Decisão sobre a fase 2 do Agentforce.</a:t>
             </a:r>
           </a:p>
         </p:txBody>

</xml_diff>

<commit_message>
Catalogo EPC: fluxo Draft/In-Review/In-Test/Released dos projetos do EPC como etapas do manual
Co-Authored-By: Claude Fable 5.1 <noreply@anthropic.com>
Claude-Session: https://claude.ai/code/session_01FufmY5Q9iS5xTS4p1D8GUr
</commit_message>
<xml_diff>
--- a/docs/deck-catalogo/Catalogo_Carga_e_Manutencao_v2_Rota_Padrao.pptx
+++ b/docs/deck-catalogo/Catalogo_Carga_e_Manutencao_v2_Rota_Padrao.pptx
@@ -3819,7 +3819,7 @@
                 <a:latin typeface="Calibri"/>
                 <a:cs typeface="Calibri"/>
               </a:rPr>
-              <a:t>Toda oferta nasce em sandbox, é testada no carrinho e só então migra, pelo IDX Workbench, a partir do projeto Released.</a:t>
+              <a:t>Toda oferta nasce em sandbox num projeto do EPC e passa por Draft, In-Review e In-Test; só em Released migra pelo IDX Workbench.</a:t>
             </a:r>
           </a:p>
         </p:txBody>
@@ -4845,7 +4845,7 @@
                 <a:latin typeface="Calibri"/>
                 <a:cs typeface="Calibri"/>
               </a:rPr>
-              <a:t>Quem cadastra e quem aprova: </a:t>
+              <a:t>Quem faz cada etapa: </a:t>
             </a:r>
             <a:r>
               <a:rPr lang="pt-BR" sz="1050.0" b="0" i="0" dirty="0">
@@ -4855,7 +4855,7 @@
                 <a:latin typeface="Calibri"/>
                 <a:cs typeface="Calibri"/>
               </a:rPr>
-              <a:t>nomes, não áreas.</a:t>
+              <a:t>o status do projeto do EPC marca a etapa: Draft (analista), In-Review (governança), In-Test (comercial no carrinho), Released (publicação). Nomes, não áreas.</a:t>
             </a:r>
           </a:p>
           <a:p>
@@ -5366,7 +5366,7 @@
                 <a:latin typeface="Calibri"/>
                 <a:cs typeface="Calibri"/>
               </a:rPr>
-              <a:t>Define e aprova ofertas, preços e promoções; responde às pendências de negócio; assina a homologação no carrinho.</a:t>
+              <a:t>Define e aprova ofertas, preços e promoções; responde às pendências de negócio; homologa no carrinho na etapa In-Test.</a:t>
             </a:r>
           </a:p>
         </p:txBody>
@@ -5460,7 +5460,7 @@
                 <a:latin typeface="Calibri"/>
                 <a:cs typeface="Calibri"/>
               </a:rPr>
-              <a:t>Cadastram no Product Designer pelo manual; exportam o DataPack; rodam o checklist pós-carga.</a:t>
+              <a:t>Abrem o projeto do EPC e cadastram no Product Designer pelo manual (Draft); rodam o checklist pós-carga em janela.</a:t>
             </a:r>
           </a:p>
         </p:txBody>
@@ -5554,7 +5554,7 @@
                 <a:latin typeface="Calibri"/>
                 <a:cs typeface="Calibri"/>
               </a:rPr>
-              <a:t>Valida o levantamento contra a org, aprova a publicação, mantém o manual e o diário de cargas.</a:t>
+              <a:t>Revisa o projeto (In-Review), marca Released e publica pelo IDX; mantém o manual e o diário de cargas.</a:t>
             </a:r>
           </a:p>
         </p:txBody>

</xml_diff>

<commit_message>
Deck catalogo: corrige sz fracionado que quebrava o PowerPoint; validacao XSD com xmllint
Co-Authored-By: Claude Fable 5.1 <noreply@anthropic.com>
Claude-Session: https://claude.ai/code/session_01FufmY5Q9iS5xTS4p1D8GUr
</commit_message>
<xml_diff>
--- a/docs/deck-catalogo/Catalogo_Carga_e_Manutencao_v2_Rota_Padrao.pptx
+++ b/docs/deck-catalogo/Catalogo_Carga_e_Manutencao_v2_Rota_Padrao.pptx
@@ -3530,7 +3530,7 @@
               <a:buNone/>
             </a:pPr>
             <a:r>
-              <a:rPr lang="pt-BR" sz="1050.0" b="0" i="0" dirty="0">
+              <a:rPr lang="pt-BR" sz="1050" b="0" i="0" dirty="0">
                 <a:solidFill>
                   <a:srgbClr val="444444"/>
                 </a:solidFill>
@@ -3671,7 +3671,7 @@
               <a:buNone/>
             </a:pPr>
             <a:r>
-              <a:rPr lang="pt-BR" sz="1050.0" b="0" i="0" dirty="0">
+              <a:rPr lang="pt-BR" sz="1050" b="0" i="0" dirty="0">
                 <a:solidFill>
                   <a:srgbClr val="444444"/>
                 </a:solidFill>
@@ -3812,7 +3812,7 @@
               <a:buNone/>
             </a:pPr>
             <a:r>
-              <a:rPr lang="pt-BR" sz="1050.0" b="0" i="0" dirty="0">
+              <a:rPr lang="pt-BR" sz="1050" b="0" i="0" dirty="0">
                 <a:solidFill>
                   <a:srgbClr val="444444"/>
                 </a:solidFill>
@@ -3953,7 +3953,7 @@
               <a:buNone/>
             </a:pPr>
             <a:r>
-              <a:rPr lang="pt-BR" sz="1050.0" b="0" i="0" dirty="0">
+              <a:rPr lang="pt-BR" sz="1050" b="0" i="0" dirty="0">
                 <a:solidFill>
                   <a:srgbClr val="444444"/>
                 </a:solidFill>
@@ -4094,7 +4094,7 @@
               <a:buNone/>
             </a:pPr>
             <a:r>
-              <a:rPr lang="pt-BR" sz="1050.0" b="0" i="0" dirty="0">
+              <a:rPr lang="pt-BR" sz="1050" b="0" i="0" dirty="0">
                 <a:solidFill>
                   <a:srgbClr val="444444"/>
                 </a:solidFill>
@@ -4235,7 +4235,7 @@
               <a:buNone/>
             </a:pPr>
             <a:r>
-              <a:rPr lang="pt-BR" sz="1050.0" b="0" i="0" dirty="0">
+              <a:rPr lang="pt-BR" sz="1050" b="0" i="0" dirty="0">
                 <a:solidFill>
                   <a:srgbClr val="444444"/>
                 </a:solidFill>
@@ -4486,7 +4486,7 @@
               <a:buNone/>
             </a:pPr>
             <a:r>
-              <a:rPr lang="pt-BR" sz="950.0" b="0" i="0" dirty="0">
+              <a:rPr lang="pt-BR" sz="950" b="0" i="0" dirty="0">
                 <a:solidFill>
                   <a:srgbClr val="D9E2F3"/>
                 </a:solidFill>
@@ -4550,7 +4550,7 @@
               <a:buNone/>
             </a:pPr>
             <a:r>
-              <a:rPr lang="pt-BR" sz="950.0" b="0" i="0" dirty="0">
+              <a:rPr lang="pt-BR" sz="950" b="0" i="0" dirty="0">
                 <a:solidFill>
                   <a:srgbClr val="D9E2F3"/>
                 </a:solidFill>
@@ -4614,7 +4614,7 @@
               <a:buNone/>
             </a:pPr>
             <a:r>
-              <a:rPr lang="pt-BR" sz="950.0" b="0" i="0" dirty="0">
+              <a:rPr lang="pt-BR" sz="950" b="0" i="0" dirty="0">
                 <a:solidFill>
                   <a:srgbClr val="D9E2F3"/>
                 </a:solidFill>
@@ -4678,7 +4678,7 @@
               <a:buNone/>
             </a:pPr>
             <a:r>
-              <a:rPr lang="pt-BR" sz="950.0" b="0" i="0" dirty="0">
+              <a:rPr lang="pt-BR" sz="950" b="0" i="0" dirty="0">
                 <a:solidFill>
                   <a:srgbClr val="D9E2F3"/>
                 </a:solidFill>
@@ -4742,7 +4742,7 @@
               <a:buNone/>
             </a:pPr>
             <a:r>
-              <a:rPr lang="pt-BR" sz="950.0" b="0" i="0" dirty="0">
+              <a:rPr lang="pt-BR" sz="950" b="0" i="0" dirty="0">
                 <a:solidFill>
                   <a:srgbClr val="D9E2F3"/>
                 </a:solidFill>
@@ -4809,7 +4809,7 @@
               <a:buChar char="•"/>
             </a:pPr>
             <a:r>
-              <a:rPr lang="pt-BR" sz="1050.0" b="1" i="0" dirty="0">
+              <a:rPr lang="pt-BR" sz="1050" b="1" i="0" dirty="0">
                 <a:solidFill>
                   <a:srgbClr val="444444"/>
                 </a:solidFill>
@@ -4819,7 +4819,7 @@
               <a:t>Pré-requisitos: </a:t>
             </a:r>
             <a:r>
-              <a:rPr lang="pt-BR" sz="1050.0" b="0" i="0" dirty="0">
+              <a:rPr lang="pt-BR" sz="1050" b="0" i="0" dirty="0">
                 <a:solidFill>
                   <a:srgbClr val="444444"/>
                 </a:solidFill>
@@ -4838,7 +4838,7 @@
               <a:buChar char="•"/>
             </a:pPr>
             <a:r>
-              <a:rPr lang="pt-BR" sz="1050.0" b="1" i="0" dirty="0">
+              <a:rPr lang="pt-BR" sz="1050" b="1" i="0" dirty="0">
                 <a:solidFill>
                   <a:srgbClr val="444444"/>
                 </a:solidFill>
@@ -4848,7 +4848,7 @@
               <a:t>Quem faz cada etapa: </a:t>
             </a:r>
             <a:r>
-              <a:rPr lang="pt-BR" sz="1050.0" b="0" i="0" dirty="0">
+              <a:rPr lang="pt-BR" sz="1050" b="0" i="0" dirty="0">
                 <a:solidFill>
                   <a:srgbClr val="444444"/>
                 </a:solidFill>
@@ -4867,7 +4867,7 @@
               <a:buChar char="•"/>
             </a:pPr>
             <a:r>
-              <a:rPr lang="pt-BR" sz="1050.0" b="1" i="0" dirty="0">
+              <a:rPr lang="pt-BR" sz="1050" b="1" i="0" dirty="0">
                 <a:solidFill>
                   <a:srgbClr val="444444"/>
                 </a:solidFill>
@@ -4877,7 +4877,7 @@
               <a:t>Passo a passo com telas: </a:t>
             </a:r>
             <a:r>
-              <a:rPr lang="pt-BR" sz="1050.0" b="0" i="0" dirty="0">
+              <a:rPr lang="pt-BR" sz="1050" b="0" i="0" dirty="0">
                 <a:solidFill>
                   <a:srgbClr val="444444"/>
                 </a:solidFill>
@@ -4896,7 +4896,7 @@
               <a:buChar char="•"/>
             </a:pPr>
             <a:r>
-              <a:rPr lang="pt-BR" sz="1050.0" b="1" i="0" dirty="0">
+              <a:rPr lang="pt-BR" sz="1050" b="1" i="0" dirty="0">
                 <a:solidFill>
                   <a:srgbClr val="444444"/>
                 </a:solidFill>
@@ -4906,7 +4906,7 @@
               <a:t>Pós-carga: </a:t>
             </a:r>
             <a:r>
-              <a:rPr lang="pt-BR" sz="1050.0" b="0" i="0" dirty="0">
+              <a:rPr lang="pt-BR" sz="1050" b="0" i="0" dirty="0">
                 <a:solidFill>
                   <a:srgbClr val="444444"/>
                 </a:solidFill>
@@ -4925,7 +4925,7 @@
               <a:buChar char="•"/>
             </a:pPr>
             <a:r>
-              <a:rPr lang="pt-BR" sz="1050.0" b="1" i="0" dirty="0">
+              <a:rPr lang="pt-BR" sz="1050" b="1" i="0" dirty="0">
                 <a:solidFill>
                   <a:srgbClr val="444444"/>
                 </a:solidFill>
@@ -4935,7 +4935,7 @@
               <a:t>Evidência: </a:t>
             </a:r>
             <a:r>
-              <a:rPr lang="pt-BR" sz="1050.0" b="0" i="0" dirty="0">
+              <a:rPr lang="pt-BR" sz="1050" b="0" i="0" dirty="0">
                 <a:solidFill>
                   <a:srgbClr val="444444"/>
                 </a:solidFill>
@@ -5002,7 +5002,7 @@
               <a:buChar char="•"/>
             </a:pPr>
             <a:r>
-              <a:rPr lang="pt-BR" sz="1050.0" b="0" i="0" dirty="0">
+              <a:rPr lang="pt-BR" sz="1050" b="0" i="0" dirty="0">
                 <a:solidFill>
                   <a:srgbClr val="444444"/>
                 </a:solidFill>
@@ -5021,7 +5021,7 @@
               <a:buChar char="•"/>
             </a:pPr>
             <a:r>
-              <a:rPr lang="pt-BR" sz="1050.0" b="0" i="0" dirty="0">
+              <a:rPr lang="pt-BR" sz="1050" b="0" i="0" dirty="0">
                 <a:solidFill>
                   <a:srgbClr val="444444"/>
                 </a:solidFill>
@@ -5040,7 +5040,7 @@
               <a:buChar char="•"/>
             </a:pPr>
             <a:r>
-              <a:rPr lang="pt-BR" sz="1050.0" b="0" i="0" dirty="0">
+              <a:rPr lang="pt-BR" sz="1050" b="0" i="0" dirty="0">
                 <a:solidFill>
                   <a:srgbClr val="444444"/>
                 </a:solidFill>
@@ -5059,7 +5059,7 @@
               <a:buChar char="•"/>
             </a:pPr>
             <a:r>
-              <a:rPr lang="pt-BR" sz="1050.0" b="0" i="0" dirty="0">
+              <a:rPr lang="pt-BR" sz="1050" b="0" i="0" dirty="0">
                 <a:solidFill>
                   <a:srgbClr val="444444"/>
                 </a:solidFill>
@@ -5078,7 +5078,7 @@
               <a:buChar char="•"/>
             </a:pPr>
             <a:r>
-              <a:rPr lang="pt-BR" sz="1050.0" b="0" i="0" dirty="0">
+              <a:rPr lang="pt-BR" sz="1050" b="0" i="0" dirty="0">
                 <a:solidFill>
                   <a:srgbClr val="444444"/>
                 </a:solidFill>
@@ -5311,7 +5311,7 @@
               <a:buNone/>
             </a:pPr>
             <a:r>
-              <a:rPr lang="pt-BR" sz="1150.0" b="1" i="0" dirty="0">
+              <a:rPr lang="pt-BR" sz="1150" b="1" i="0" dirty="0">
                 <a:solidFill>
                   <a:srgbClr val="FFFFFF"/>
                 </a:solidFill>
@@ -5359,7 +5359,7 @@
               <a:buNone/>
             </a:pPr>
             <a:r>
-              <a:rPr lang="pt-BR" sz="1050.0" b="0" i="0" dirty="0">
+              <a:rPr lang="pt-BR" sz="1050" b="0" i="0" dirty="0">
                 <a:solidFill>
                   <a:srgbClr val="444444"/>
                 </a:solidFill>
@@ -5405,7 +5405,7 @@
               <a:buNone/>
             </a:pPr>
             <a:r>
-              <a:rPr lang="pt-BR" sz="1150.0" b="1" i="0" dirty="0">
+              <a:rPr lang="pt-BR" sz="1150" b="1" i="0" dirty="0">
                 <a:solidFill>
                   <a:srgbClr val="FFFFFF"/>
                 </a:solidFill>
@@ -5453,7 +5453,7 @@
               <a:buNone/>
             </a:pPr>
             <a:r>
-              <a:rPr lang="pt-BR" sz="1050.0" b="0" i="0" dirty="0">
+              <a:rPr lang="pt-BR" sz="1050" b="0" i="0" dirty="0">
                 <a:solidFill>
                   <a:srgbClr val="444444"/>
                 </a:solidFill>
@@ -5499,7 +5499,7 @@
               <a:buNone/>
             </a:pPr>
             <a:r>
-              <a:rPr lang="pt-BR" sz="1150.0" b="1" i="0" dirty="0">
+              <a:rPr lang="pt-BR" sz="1150" b="1" i="0" dirty="0">
                 <a:solidFill>
                   <a:srgbClr val="FFFFFF"/>
                 </a:solidFill>
@@ -5547,7 +5547,7 @@
               <a:buNone/>
             </a:pPr>
             <a:r>
-              <a:rPr lang="pt-BR" sz="1050.0" b="0" i="0" dirty="0">
+              <a:rPr lang="pt-BR" sz="1050" b="0" i="0" dirty="0">
                 <a:solidFill>
                   <a:srgbClr val="444444"/>
                 </a:solidFill>
@@ -5593,7 +5593,7 @@
               <a:buNone/>
             </a:pPr>
             <a:r>
-              <a:rPr lang="pt-BR" sz="1150.0" b="1" i="0" dirty="0">
+              <a:rPr lang="pt-BR" sz="1150" b="1" i="0" dirty="0">
                 <a:solidFill>
                   <a:srgbClr val="FFFFFF"/>
                 </a:solidFill>
@@ -5641,7 +5641,7 @@
               <a:buNone/>
             </a:pPr>
             <a:r>
-              <a:rPr lang="pt-BR" sz="1050.0" b="0" i="0" dirty="0">
+              <a:rPr lang="pt-BR" sz="1050" b="0" i="0" dirty="0">
                 <a:solidFill>
                   <a:srgbClr val="444444"/>
                 </a:solidFill>
@@ -5687,7 +5687,7 @@
               <a:buNone/>
             </a:pPr>
             <a:r>
-              <a:rPr lang="pt-BR" sz="1150.0" b="1" i="0" dirty="0">
+              <a:rPr lang="pt-BR" sz="1150" b="1" i="0" dirty="0">
                 <a:solidFill>
                   <a:srgbClr val="FFFFFF"/>
                 </a:solidFill>
@@ -5735,7 +5735,7 @@
               <a:buNone/>
             </a:pPr>
             <a:r>
-              <a:rPr lang="pt-BR" sz="1050.0" b="0" i="0" dirty="0">
+              <a:rPr lang="pt-BR" sz="1050" b="0" i="0" dirty="0">
                 <a:solidFill>
                   <a:srgbClr val="444444"/>
                 </a:solidFill>
@@ -6106,7 +6106,7 @@
               <a:buNone/>
             </a:pPr>
             <a:r>
-              <a:rPr lang="pt-BR" sz="1050.0" b="0" i="0" dirty="0">
+              <a:rPr lang="pt-BR" sz="1050" b="0" i="0" dirty="0">
                 <a:solidFill>
                   <a:srgbClr val="444444"/>
                 </a:solidFill>
@@ -6152,7 +6152,7 @@
               <a:buNone/>
             </a:pPr>
             <a:r>
-              <a:rPr lang="pt-BR" sz="1050.0" b="0" i="0" dirty="0">
+              <a:rPr lang="pt-BR" sz="1050" b="0" i="0" dirty="0">
                 <a:solidFill>
                   <a:srgbClr val="444444"/>
                 </a:solidFill>
@@ -6198,7 +6198,7 @@
               <a:buNone/>
             </a:pPr>
             <a:r>
-              <a:rPr lang="pt-BR" sz="1050.0" b="0" i="0" dirty="0">
+              <a:rPr lang="pt-BR" sz="1050" b="0" i="0" dirty="0">
                 <a:solidFill>
                   <a:srgbClr val="444444"/>
                 </a:solidFill>
@@ -6244,7 +6244,7 @@
               <a:buNone/>
             </a:pPr>
             <a:r>
-              <a:rPr lang="pt-BR" sz="1050.0" b="0" i="0" dirty="0">
+              <a:rPr lang="pt-BR" sz="1050" b="0" i="0" dirty="0">
                 <a:solidFill>
                   <a:srgbClr val="444444"/>
                 </a:solidFill>
@@ -6290,7 +6290,7 @@
               <a:buNone/>
             </a:pPr>
             <a:r>
-              <a:rPr lang="pt-BR" sz="1050.0" b="0" i="0" dirty="0">
+              <a:rPr lang="pt-BR" sz="1050" b="0" i="0" dirty="0">
                 <a:solidFill>
                   <a:srgbClr val="444444"/>
                 </a:solidFill>
@@ -6336,7 +6336,7 @@
               <a:buNone/>
             </a:pPr>
             <a:r>
-              <a:rPr lang="pt-BR" sz="1050.0" b="0" i="0" dirty="0">
+              <a:rPr lang="pt-BR" sz="1050" b="0" i="0" dirty="0">
                 <a:solidFill>
                   <a:srgbClr val="444444"/>
                 </a:solidFill>
@@ -6382,7 +6382,7 @@
               <a:buNone/>
             </a:pPr>
             <a:r>
-              <a:rPr lang="pt-BR" sz="1050.0" b="0" i="0" dirty="0">
+              <a:rPr lang="pt-BR" sz="1050" b="0" i="0" dirty="0">
                 <a:solidFill>
                   <a:srgbClr val="444444"/>
                 </a:solidFill>
@@ -6428,7 +6428,7 @@
               <a:buNone/>
             </a:pPr>
             <a:r>
-              <a:rPr lang="pt-BR" sz="1050.0" b="0" i="0" dirty="0">
+              <a:rPr lang="pt-BR" sz="1050" b="0" i="0" dirty="0">
                 <a:solidFill>
                   <a:srgbClr val="444444"/>
                 </a:solidFill>
@@ -6474,7 +6474,7 @@
               <a:buNone/>
             </a:pPr>
             <a:r>
-              <a:rPr lang="pt-BR" sz="1050.0" b="0" i="0" dirty="0">
+              <a:rPr lang="pt-BR" sz="1050" b="0" i="0" dirty="0">
                 <a:solidFill>
                   <a:srgbClr val="444444"/>
                 </a:solidFill>
@@ -6520,7 +6520,7 @@
               <a:buNone/>
             </a:pPr>
             <a:r>
-              <a:rPr lang="pt-BR" sz="1050.0" b="0" i="0" dirty="0">
+              <a:rPr lang="pt-BR" sz="1050" b="0" i="0" dirty="0">
                 <a:solidFill>
                   <a:srgbClr val="444444"/>
                 </a:solidFill>
@@ -6566,7 +6566,7 @@
               <a:buNone/>
             </a:pPr>
             <a:r>
-              <a:rPr lang="pt-BR" sz="1050.0" b="0" i="0" dirty="0">
+              <a:rPr lang="pt-BR" sz="1050" b="0" i="0" dirty="0">
                 <a:solidFill>
                   <a:srgbClr val="444444"/>
                 </a:solidFill>
@@ -6612,7 +6612,7 @@
               <a:buNone/>
             </a:pPr>
             <a:r>
-              <a:rPr lang="pt-BR" sz="1050.0" b="0" i="0" dirty="0">
+              <a:rPr lang="pt-BR" sz="1050" b="0" i="0" dirty="0">
                 <a:solidFill>
                   <a:srgbClr val="444444"/>
                 </a:solidFill>
@@ -6658,7 +6658,7 @@
               <a:buNone/>
             </a:pPr>
             <a:r>
-              <a:rPr lang="pt-BR" sz="1050.0" b="0" i="0" dirty="0">
+              <a:rPr lang="pt-BR" sz="1050" b="0" i="0" dirty="0">
                 <a:solidFill>
                   <a:srgbClr val="444444"/>
                 </a:solidFill>
@@ -6704,7 +6704,7 @@
               <a:buNone/>
             </a:pPr>
             <a:r>
-              <a:rPr lang="pt-BR" sz="1050.0" b="0" i="0" dirty="0">
+              <a:rPr lang="pt-BR" sz="1050" b="0" i="0" dirty="0">
                 <a:solidFill>
                   <a:srgbClr val="444444"/>
                 </a:solidFill>
@@ -6750,7 +6750,7 @@
               <a:buNone/>
             </a:pPr>
             <a:r>
-              <a:rPr lang="pt-BR" sz="1050.0" b="0" i="0" dirty="0">
+              <a:rPr lang="pt-BR" sz="1050" b="0" i="0" dirty="0">
                 <a:solidFill>
                   <a:srgbClr val="444444"/>
                 </a:solidFill>
@@ -6796,7 +6796,7 @@
               <a:buNone/>
             </a:pPr>
             <a:r>
-              <a:rPr lang="pt-BR" sz="1050.0" b="0" i="0" dirty="0">
+              <a:rPr lang="pt-BR" sz="1050" b="0" i="0" dirty="0">
                 <a:solidFill>
                   <a:srgbClr val="444444"/>
                 </a:solidFill>
@@ -6842,7 +6842,7 @@
               <a:buNone/>
             </a:pPr>
             <a:r>
-              <a:rPr lang="pt-BR" sz="1050.0" b="0" i="0" dirty="0">
+              <a:rPr lang="pt-BR" sz="1050" b="0" i="0" dirty="0">
                 <a:solidFill>
                   <a:srgbClr val="444444"/>
                 </a:solidFill>
@@ -6888,7 +6888,7 @@
               <a:buNone/>
             </a:pPr>
             <a:r>
-              <a:rPr lang="pt-BR" sz="1050.0" b="0" i="0" dirty="0">
+              <a:rPr lang="pt-BR" sz="1050" b="0" i="0" dirty="0">
                 <a:solidFill>
                   <a:srgbClr val="444444"/>
                 </a:solidFill>
@@ -6934,7 +6934,7 @@
               <a:buNone/>
             </a:pPr>
             <a:r>
-              <a:rPr lang="pt-BR" sz="1050.0" b="0" i="0" dirty="0">
+              <a:rPr lang="pt-BR" sz="1050" b="0" i="0" dirty="0">
                 <a:solidFill>
                   <a:srgbClr val="444444"/>
                 </a:solidFill>
@@ -6980,7 +6980,7 @@
               <a:buNone/>
             </a:pPr>
             <a:r>
-              <a:rPr lang="pt-BR" sz="1050.0" b="0" i="0" dirty="0">
+              <a:rPr lang="pt-BR" sz="1050" b="0" i="0" dirty="0">
                 <a:solidFill>
                   <a:srgbClr val="444444"/>
                 </a:solidFill>
@@ -7026,7 +7026,7 @@
               <a:buNone/>
             </a:pPr>
             <a:r>
-              <a:rPr lang="pt-BR" sz="1050.0" b="0" i="0" dirty="0">
+              <a:rPr lang="pt-BR" sz="1050" b="0" i="0" dirty="0">
                 <a:solidFill>
                   <a:srgbClr val="444444"/>
                 </a:solidFill>
@@ -7837,7 +7837,7 @@
               <a:buChar char="•"/>
             </a:pPr>
             <a:r>
-              <a:rPr lang="pt-BR" sz="1050.0" b="0" i="0" dirty="0">
+              <a:rPr lang="pt-BR" sz="1050" b="0" i="0" dirty="0">
                 <a:solidFill>
                   <a:srgbClr val="444444"/>
                 </a:solidFill>
@@ -7856,7 +7856,7 @@
               <a:buChar char="•"/>
             </a:pPr>
             <a:r>
-              <a:rPr lang="pt-BR" sz="1050.0" b="0" i="0" dirty="0">
+              <a:rPr lang="pt-BR" sz="1050" b="0" i="0" dirty="0">
                 <a:solidFill>
                   <a:srgbClr val="444444"/>
                 </a:solidFill>
@@ -7923,7 +7923,7 @@
               <a:buChar char="•"/>
             </a:pPr>
             <a:r>
-              <a:rPr lang="pt-BR" sz="1050.0" b="0" i="0" dirty="0">
+              <a:rPr lang="pt-BR" sz="1050" b="0" i="0" dirty="0">
                 <a:solidFill>
                   <a:srgbClr val="444444"/>
                 </a:solidFill>
@@ -7942,7 +7942,7 @@
               <a:buChar char="•"/>
             </a:pPr>
             <a:r>
-              <a:rPr lang="pt-BR" sz="1050.0" b="0" i="0" dirty="0">
+              <a:rPr lang="pt-BR" sz="1050" b="0" i="0" dirty="0">
                 <a:solidFill>
                   <a:srgbClr val="444444"/>
                 </a:solidFill>
@@ -8009,7 +8009,7 @@
               <a:buChar char="•"/>
             </a:pPr>
             <a:r>
-              <a:rPr lang="pt-BR" sz="1050.0" b="0" i="0" dirty="0">
+              <a:rPr lang="pt-BR" sz="1050" b="0" i="0" dirty="0">
                 <a:solidFill>
                   <a:srgbClr val="444444"/>
                 </a:solidFill>
@@ -8028,7 +8028,7 @@
               <a:buChar char="•"/>
             </a:pPr>
             <a:r>
-              <a:rPr lang="pt-BR" sz="1050.0" b="0" i="0" dirty="0">
+              <a:rPr lang="pt-BR" sz="1050" b="0" i="0" dirty="0">
                 <a:solidFill>
                   <a:srgbClr val="444444"/>
                 </a:solidFill>
@@ -8095,7 +8095,7 @@
               <a:buChar char="•"/>
             </a:pPr>
             <a:r>
-              <a:rPr lang="pt-BR" sz="1050.0" b="0" i="0" dirty="0">
+              <a:rPr lang="pt-BR" sz="1050" b="0" i="0" dirty="0">
                 <a:solidFill>
                   <a:srgbClr val="444444"/>
                 </a:solidFill>
@@ -8114,7 +8114,7 @@
               <a:buChar char="•"/>
             </a:pPr>
             <a:r>
-              <a:rPr lang="pt-BR" sz="1050.0" b="0" i="0" dirty="0">
+              <a:rPr lang="pt-BR" sz="1050" b="0" i="0" dirty="0">
                 <a:solidFill>
                   <a:srgbClr val="444444"/>
                 </a:solidFill>
@@ -8160,7 +8160,7 @@
               <a:buNone/>
             </a:pPr>
             <a:r>
-              <a:rPr lang="pt-BR" sz="1050.0" b="1" i="0" dirty="0">
+              <a:rPr lang="pt-BR" sz="1050" b="1" i="0" dirty="0">
                 <a:solidFill>
                   <a:srgbClr val="FFFFFF"/>
                 </a:solidFill>
@@ -12910,7 +12910,7 @@
               <a:buChar char="•"/>
             </a:pPr>
             <a:r>
-              <a:rPr lang="pt-BR" sz="1050.0" b="0" i="0" dirty="0">
+              <a:rPr lang="pt-BR" sz="1050" b="0" i="0" dirty="0">
                 <a:solidFill>
                   <a:srgbClr val="444444"/>
                 </a:solidFill>
@@ -12929,7 +12929,7 @@
               <a:buChar char="•"/>
             </a:pPr>
             <a:r>
-              <a:rPr lang="pt-BR" sz="1050.0" b="0" i="0" dirty="0">
+              <a:rPr lang="pt-BR" sz="1050" b="0" i="0" dirty="0">
                 <a:solidFill>
                   <a:srgbClr val="444444"/>
                 </a:solidFill>
@@ -13157,24 +13157,6 @@
           </a:bodyPr>
           <a:lstStyle/>
           <a:p>
-            <a:pPr algn="l">
-              <a:spcAft>
-                <a:spcPts val="600"/>
-              </a:spcAft>
-              <a:buNone/>
-            </a:pPr>
-            <a:r>
-              <a:rPr lang="pt-BR" sz="400" b="1" i="0" dirty="0">
-                <a:solidFill>
-                  <a:srgbClr val="1B7A4E"/>
-                </a:solidFill>
-                <a:latin typeface="Calibri"/>
-                <a:cs typeface="Calibri"/>
-              </a:rPr>
-              <a:t/>
-            </a:r>
-          </a:p>
-          <a:p>
             <a:pPr algn="l" marL="228600" indent="-228600">
               <a:spcAft>
                 <a:spcPts val="500"/>
@@ -13308,24 +13290,6 @@
           </a:bodyPr>
           <a:lstStyle/>
           <a:p>
-            <a:pPr algn="l">
-              <a:spcAft>
-                <a:spcPts val="600"/>
-              </a:spcAft>
-              <a:buNone/>
-            </a:pPr>
-            <a:r>
-              <a:rPr lang="pt-BR" sz="400" b="1" i="0" dirty="0">
-                <a:solidFill>
-                  <a:srgbClr val="2E75B6"/>
-                </a:solidFill>
-                <a:latin typeface="Calibri"/>
-                <a:cs typeface="Calibri"/>
-              </a:rPr>
-              <a:t/>
-            </a:r>
-          </a:p>
-          <a:p>
             <a:pPr algn="l" marL="228600" indent="-228600">
               <a:spcAft>
                 <a:spcPts val="500"/>
@@ -13459,24 +13423,6 @@
           </a:bodyPr>
           <a:lstStyle/>
           <a:p>
-            <a:pPr algn="l">
-              <a:spcAft>
-                <a:spcPts val="600"/>
-              </a:spcAft>
-              <a:buNone/>
-            </a:pPr>
-            <a:r>
-              <a:rPr lang="pt-BR" sz="400" b="1" i="0" dirty="0">
-                <a:solidFill>
-                  <a:srgbClr val="2E75B6"/>
-                </a:solidFill>
-                <a:latin typeface="Calibri"/>
-                <a:cs typeface="Calibri"/>
-              </a:rPr>
-              <a:t/>
-            </a:r>
-          </a:p>
-          <a:p>
             <a:pPr algn="l" marL="228600" indent="-228600">
               <a:spcAft>
                 <a:spcPts val="500"/>
@@ -13609,24 +13555,6 @@
             <a:normAutofit/>
           </a:bodyPr>
           <a:lstStyle/>
-          <a:p>
-            <a:pPr algn="l">
-              <a:spcAft>
-                <a:spcPts val="600"/>
-              </a:spcAft>
-              <a:buNone/>
-            </a:pPr>
-            <a:r>
-              <a:rPr lang="pt-BR" sz="400" b="1" i="0" dirty="0">
-                <a:solidFill>
-                  <a:srgbClr val="1F3864"/>
-                </a:solidFill>
-                <a:latin typeface="Calibri"/>
-                <a:cs typeface="Calibri"/>
-              </a:rPr>
-              <a:t/>
-            </a:r>
-          </a:p>
           <a:p>
             <a:pPr algn="l" marL="228600" indent="-228600">
               <a:spcAft>

</xml_diff>